<commit_message>
adiciona metricas no slides
</commit_message>
<xml_diff>
--- a/Priceless_Bank_Apresentacao.pptx
+++ b/Priceless_Bank_Apresentacao.pptx
@@ -4352,7 +4352,7 @@
                 <a:ea typeface="Calibri" pitchFamily="34" charset="-122"/>
                 <a:cs typeface="Calibri" pitchFamily="34" charset="-120"/>
               </a:rPr>
-              <a:t>Programa de domicílio de renda</a:t>
+              <a:t>Abertura de conta 100% digital</a:t>
             </a:r>
             <a:endParaRPr lang="en-US" sz="1300" dirty="0"/>
           </a:p>
@@ -4430,7 +4430,7 @@
                 <a:ea typeface="Calibri" pitchFamily="34" charset="-122"/>
                 <a:cs typeface="Calibri" pitchFamily="34" charset="-120"/>
               </a:rPr>
-              <a:t>Alto</a:t>
+              <a:t>Médio</a:t>
             </a:r>
             <a:endParaRPr lang="en-US" sz="1200" dirty="0"/>
           </a:p>
@@ -4508,7 +4508,7 @@
                 <a:ea typeface="Calibri" pitchFamily="34" charset="-122"/>
                 <a:cs typeface="Calibri" pitchFamily="34" charset="-120"/>
               </a:rPr>
-              <a:t>Abertura de conta 100% digital</a:t>
+              <a:t>Investimento que vira limite de cartão</a:t>
             </a:r>
             <a:endParaRPr lang="en-US" sz="1300" dirty="0"/>
           </a:p>
@@ -4686,7 +4686,7 @@
                 <a:ea typeface="Calibri" pitchFamily="34" charset="-122"/>
                 <a:cs typeface="Calibri" pitchFamily="34" charset="-120"/>
               </a:rPr>
-              <a:t>Investimento que vira limite de cartão</a:t>
+              <a:t>Ativação assistida de cartão</a:t>
             </a:r>
             <a:endParaRPr lang="en-US" sz="1300" dirty="0"/>
           </a:p>
@@ -4725,7 +4725,7 @@
                 <a:ea typeface="Calibri" pitchFamily="34" charset="-122"/>
                 <a:cs typeface="Calibri" pitchFamily="34" charset="-120"/>
               </a:rPr>
-              <a:t>Alto</a:t>
+              <a:t>Médio</a:t>
             </a:r>
             <a:endParaRPr lang="en-US" sz="1200" dirty="0"/>
           </a:p>
@@ -4764,7 +4764,7 @@
                 <a:ea typeface="Calibri" pitchFamily="34" charset="-122"/>
                 <a:cs typeface="Calibri" pitchFamily="34" charset="-120"/>
               </a:rPr>
-              <a:t>Médio</a:t>
+              <a:t>Baixo</a:t>
             </a:r>
             <a:endParaRPr lang="en-US" sz="1200" dirty="0"/>
           </a:p>
@@ -4842,7 +4842,7 @@
                 <a:ea typeface="Calibri" pitchFamily="34" charset="-122"/>
                 <a:cs typeface="Calibri" pitchFamily="34" charset="-120"/>
               </a:rPr>
-              <a:t>Ativação assistida de cartão</a:t>
+              <a:t>Investigação técnica do PIX</a:t>
             </a:r>
             <a:endParaRPr lang="en-US" sz="1300" dirty="0"/>
           </a:p>
@@ -4920,7 +4920,7 @@
                 <a:ea typeface="Calibri" pitchFamily="34" charset="-122"/>
                 <a:cs typeface="Calibri" pitchFamily="34" charset="-120"/>
               </a:rPr>
-              <a:t>Baixo</a:t>
+              <a:t>Médio</a:t>
             </a:r>
             <a:endParaRPr lang="en-US" sz="1200" dirty="0"/>
           </a:p>
@@ -4928,91 +4928,30 @@
       </p:sp>
       <p:sp>
         <p:nvSpPr>
-          <p:cNvPr id="36" name="Shape 34"/>
-          <p:cNvSpPr/>
-          <p:nvPr/>
-        </p:nvSpPr>
-        <p:spPr>
-          <a:xfrm>
-            <a:off x="640080" y="5495544"/>
-            <a:ext cx="10881360" cy="512064"/>
-          </a:xfrm>
-          <a:prstGeom prst="roundRect">
-            <a:avLst>
-              <a:gd name="adj" fmla="val 8929"/>
-            </a:avLst>
-          </a:prstGeom>
-          <a:solidFill>
-            <a:srgbClr val="F4F6FA"/>
-          </a:solidFill>
-          <a:ln/>
-        </p:spPr>
-      </p:sp>
-      <p:sp>
-        <p:nvSpPr>
-          <p:cNvPr id="37" name="Text 35"/>
-          <p:cNvSpPr/>
-          <p:nvPr/>
-        </p:nvSpPr>
-        <p:spPr>
-          <a:xfrm>
-            <a:off x="777240" y="5550408"/>
-            <a:ext cx="548640" cy="384048"/>
-          </a:xfrm>
-          <a:prstGeom prst="rect">
-            <a:avLst/>
-          </a:prstGeom>
-          <a:noFill/>
-          <a:ln/>
-        </p:spPr>
-        <p:txBody>
-          <a:bodyPr wrap="square" lIns="0" tIns="0" rIns="0" bIns="0" rtlCol="0" anchor="ctr"/>
-          <a:lstStyle/>
-          <a:p>
-            <a:pPr indent="0" marL="0">
-              <a:buNone/>
-            </a:pPr>
-            <a:r>
-              <a:rPr lang="en-US" sz="1400" b="1" dirty="0">
-                <a:solidFill>
-                  <a:srgbClr val="5A6784"/>
-                </a:solidFill>
-                <a:latin typeface="Cambria" pitchFamily="34" charset="0"/>
-                <a:ea typeface="Cambria" pitchFamily="34" charset="-122"/>
-                <a:cs typeface="Cambria" pitchFamily="34" charset="-120"/>
-              </a:rPr>
-              <a:t>7ª</a:t>
-            </a:r>
-            <a:endParaRPr lang="en-US" sz="1400" dirty="0"/>
-          </a:p>
-        </p:txBody>
-      </p:sp>
-      <p:sp>
-        <p:nvSpPr>
-          <p:cNvPr id="38" name="Text 36"/>
-          <p:cNvSpPr/>
-          <p:nvPr/>
-        </p:nvSpPr>
-        <p:spPr>
-          <a:xfrm>
-            <a:off x="1417320" y="5550408"/>
-            <a:ext cx="6766560" cy="384048"/>
-          </a:xfrm>
-          <a:prstGeom prst="rect">
-            <a:avLst/>
-          </a:prstGeom>
-          <a:noFill/>
-          <a:ln/>
-        </p:spPr>
-        <p:txBody>
-          <a:bodyPr wrap="square" lIns="0" tIns="0" rIns="0" bIns="0" rtlCol="0" anchor="ctr"/>
-          <a:lstStyle/>
-          <a:p>
-            <a:pPr indent="0" marL="0">
-              <a:buNone/>
-            </a:pPr>
-            <a:r>
-              <a:rPr lang="en-US" sz="1300" dirty="0">
+          <p:cNvPr id="36" name="Text 34"/>
+          <p:cNvSpPr/>
+          <p:nvPr/>
+        </p:nvSpPr>
+        <p:spPr>
+          <a:xfrm>
+            <a:off x="640080" y="5806440"/>
+            <a:ext cx="10881360" cy="365760"/>
+          </a:xfrm>
+          <a:prstGeom prst="rect">
+            <a:avLst/>
+          </a:prstGeom>
+          <a:noFill/>
+          <a:ln/>
+        </p:spPr>
+        <p:txBody>
+          <a:bodyPr wrap="square" lIns="0" tIns="0" rIns="0" bIns="0" rtlCol="0" anchor="ctr"/>
+          <a:lstStyle/>
+          <a:p>
+            <a:pPr indent="0" marL="0">
+              <a:buNone/>
+            </a:pPr>
+            <a:r>
+              <a:rPr lang="en-US" sz="1300" i="1" dirty="0">
                 <a:solidFill>
                   <a:srgbClr val="13223F"/>
                 </a:solidFill>
@@ -5020,124 +4959,7 @@
                 <a:ea typeface="Calibri" pitchFamily="34" charset="-122"/>
                 <a:cs typeface="Calibri" pitchFamily="34" charset="-120"/>
               </a:rPr>
-              <a:t>Investigação técnica do PIX</a:t>
-            </a:r>
-            <a:endParaRPr lang="en-US" sz="1300" dirty="0"/>
-          </a:p>
-        </p:txBody>
-      </p:sp>
-      <p:sp>
-        <p:nvSpPr>
-          <p:cNvPr id="39" name="Text 37"/>
-          <p:cNvSpPr/>
-          <p:nvPr/>
-        </p:nvSpPr>
-        <p:spPr>
-          <a:xfrm>
-            <a:off x="7726680" y="5550408"/>
-            <a:ext cx="1463040" cy="384048"/>
-          </a:xfrm>
-          <a:prstGeom prst="rect">
-            <a:avLst/>
-          </a:prstGeom>
-          <a:noFill/>
-          <a:ln/>
-        </p:spPr>
-        <p:txBody>
-          <a:bodyPr wrap="square" lIns="0" tIns="0" rIns="0" bIns="0" rtlCol="0" anchor="ctr"/>
-          <a:lstStyle/>
-          <a:p>
-            <a:pPr indent="0" marL="0">
-              <a:buNone/>
-            </a:pPr>
-            <a:r>
-              <a:rPr lang="en-US" sz="1200" dirty="0">
-                <a:solidFill>
-                  <a:srgbClr val="5A6784"/>
-                </a:solidFill>
-                <a:latin typeface="Calibri" pitchFamily="34" charset="0"/>
-                <a:ea typeface="Calibri" pitchFamily="34" charset="-122"/>
-                <a:cs typeface="Calibri" pitchFamily="34" charset="-120"/>
-              </a:rPr>
-              <a:t>Médio</a:t>
-            </a:r>
-            <a:endParaRPr lang="en-US" sz="1200" dirty="0"/>
-          </a:p>
-        </p:txBody>
-      </p:sp>
-      <p:sp>
-        <p:nvSpPr>
-          <p:cNvPr id="40" name="Text 38"/>
-          <p:cNvSpPr/>
-          <p:nvPr/>
-        </p:nvSpPr>
-        <p:spPr>
-          <a:xfrm>
-            <a:off x="9555480" y="5550408"/>
-            <a:ext cx="1463040" cy="384048"/>
-          </a:xfrm>
-          <a:prstGeom prst="rect">
-            <a:avLst/>
-          </a:prstGeom>
-          <a:noFill/>
-          <a:ln/>
-        </p:spPr>
-        <p:txBody>
-          <a:bodyPr wrap="square" lIns="0" tIns="0" rIns="0" bIns="0" rtlCol="0" anchor="ctr"/>
-          <a:lstStyle/>
-          <a:p>
-            <a:pPr indent="0" marL="0">
-              <a:buNone/>
-            </a:pPr>
-            <a:r>
-              <a:rPr lang="en-US" sz="1200" dirty="0">
-                <a:solidFill>
-                  <a:srgbClr val="5A6784"/>
-                </a:solidFill>
-                <a:latin typeface="Calibri" pitchFamily="34" charset="0"/>
-                <a:ea typeface="Calibri" pitchFamily="34" charset="-122"/>
-                <a:cs typeface="Calibri" pitchFamily="34" charset="-120"/>
-              </a:rPr>
-              <a:t>Médio</a:t>
-            </a:r>
-            <a:endParaRPr lang="en-US" sz="1200" dirty="0"/>
-          </a:p>
-        </p:txBody>
-      </p:sp>
-      <p:sp>
-        <p:nvSpPr>
-          <p:cNvPr id="41" name="Text 39"/>
-          <p:cNvSpPr/>
-          <p:nvPr/>
-        </p:nvSpPr>
-        <p:spPr>
-          <a:xfrm>
-            <a:off x="640080" y="6172200"/>
-            <a:ext cx="10881360" cy="365760"/>
-          </a:xfrm>
-          <a:prstGeom prst="rect">
-            <a:avLst/>
-          </a:prstGeom>
-          <a:noFill/>
-          <a:ln/>
-        </p:spPr>
-        <p:txBody>
-          <a:bodyPr wrap="square" lIns="0" tIns="0" rIns="0" bIns="0" rtlCol="0" anchor="ctr"/>
-          <a:lstStyle/>
-          <a:p>
-            <a:pPr indent="0" marL="0">
-              <a:buNone/>
-            </a:pPr>
-            <a:r>
-              <a:rPr lang="en-US" sz="1300" i="1" dirty="0">
-                <a:solidFill>
-                  <a:srgbClr val="13223F"/>
-                </a:solidFill>
-                <a:latin typeface="Calibri" pitchFamily="34" charset="0"/>
-                <a:ea typeface="Calibri" pitchFamily="34" charset="-122"/>
-                <a:cs typeface="Calibri" pitchFamily="34" charset="-120"/>
-              </a:rPr>
-              <a:t>As duas primeiras custam pouco e destravam o resto. A terceira resolve a raiz, e por isso começa junto mesmo sendo a mais lenta.</a:t>
+              <a:t>As duas primeiras custam pouco e destravam o resto. As demais exigem projeto e entram em paralelo, sem esperar a primeira terminar.</a:t>
             </a:r>
             <a:endParaRPr lang="en-US" sz="1300" dirty="0"/>
           </a:p>
@@ -6114,7 +5936,7 @@
                 <a:ea typeface="Calibri" pitchFamily="34" charset="-122"/>
                 <a:cs typeface="Calibri" pitchFamily="34" charset="-120"/>
               </a:rPr>
-              <a:t>Domicílio de renda em escala</a:t>
+              <a:t>Rendimento no saldo em conta</a:t>
             </a:r>
             <a:endParaRPr lang="en-US" sz="1250" dirty="0"/>
           </a:p>
@@ -6204,7 +6026,7 @@
                 <a:ea typeface="Calibri" pitchFamily="34" charset="-122"/>
                 <a:cs typeface="Calibri" pitchFamily="34" charset="-120"/>
               </a:rPr>
-              <a:t>O salário passa a cair aqui</a:t>
+              <a:t>O banco vira a opção padrão</a:t>
             </a:r>
             <a:endParaRPr lang="en-US" sz="1200" dirty="0"/>
           </a:p>

</xml_diff>